<commit_message>
docs(team): update official Roll No and PRN No for all 4 team members across all project documents, presentations, PDFs, UI badges, README, and AI dossier
</commit_message>
<xml_diff>
--- a/VERNALEDGER_AI_MERCHANT_PRO_PRESENTATION.pptx
+++ b/VERNALEDGER_AI_MERCHANT_PRO_PRESENTATION.pptx
@@ -3668,8 +3668,8 @@
         </p:nvSpPr>
         <p:spPr>
           <a:xfrm>
-            <a:off x="1645920" y="2926080"/>
-            <a:ext cx="8899855" cy="1645920"/>
+            <a:off x="1097280" y="2834640"/>
+            <a:ext cx="9997135" cy="2011680"/>
           </a:xfrm>
           <a:prstGeom prst="roundRect">
             <a:avLst/>
@@ -3715,7 +3715,7 @@
           </a:p>
           <a:p>
             <a:pPr algn="ctr">
-              <a:defRPr sz="1300" b="1">
+              <a:defRPr sz="1100" b="1">
                 <a:solidFill>
                   <a:srgbClr val="F8FAFC"/>
                 </a:solidFill>
@@ -3723,7 +3723,20 @@
               </a:defRPr>
             </a:pPr>
             <a:r>
-              <a:t>1. Sanket Kirdat       •  2. Sakshi Bhagat       •  3. Vaishnavi Dhawale       •  4. Rushikesh Mulik</a:t>
+              <a:t>1. Sanket Kirdat (Roll: 4060 | PRN: 24065451263508)   •   2. Sakshi Bhagat (Roll: 4054 | PRN: 24065451263502)</a:t>
+            </a:r>
+          </a:p>
+          <a:p>
+            <a:pPr algn="ctr">
+              <a:defRPr sz="1100" b="1">
+                <a:solidFill>
+                  <a:srgbClr val="F8FAFC"/>
+                </a:solidFill>
+                <a:latin typeface="Segoe UI"/>
+              </a:defRPr>
+            </a:pPr>
+            <a:r>
+              <a:t>3. Vaishnavi Dhavale (Roll: 4056 | PRN: 24065451263504)   •   4. Rushikesh Mulik (Roll: 4004 | PRN: 23065451263005)</a:t>
             </a:r>
           </a:p>
           <a:p>
@@ -17773,8 +17786,8 @@
         </p:nvSpPr>
         <p:spPr>
           <a:xfrm>
-            <a:off x="2286000" y="4114800"/>
-            <a:ext cx="7619695" cy="1645920"/>
+            <a:off x="1371600" y="3931920"/>
+            <a:ext cx="9448495" cy="2011680"/>
           </a:xfrm>
           <a:prstGeom prst="roundRect">
             <a:avLst/>
@@ -17828,7 +17841,11 @@
               </a:defRPr>
             </a:pPr>
             <a:r>
-              <a:t>Project Team: Sanket Kirdat • Sakshi Bhagat • Vaishnavi Dhawale • Rushikesh Mulik</a:t>
+              <a:t>Project Team: Sanket Kirdat (Roll: 4060 | PRN: 24065451263508) • Sakshi Bhagat (Roll: 4054 | PRN: 24065451263502)</a:t>
+            </a:r>
+            <a:br/>
+            <a:r>
+              <a:t>Vaishnavi Dhavale (Roll: 4056 | PRN: 24065451263504) • Rushikesh Mulik (Roll: 4004 | PRN: 23065451263005)</a:t>
             </a:r>
           </a:p>
           <a:p>

</xml_diff>

<commit_message>
docs(team): simplify student roles to standard, clear, and easy-to-explain designations across all documents and app
</commit_message>
<xml_diff>
--- a/VERNALEDGER_AI_MERCHANT_PRO_PRESENTATION.pptx
+++ b/VERNALEDGER_AI_MERCHANT_PRO_PRESENTATION.pptx
@@ -3723,7 +3723,7 @@
               </a:defRPr>
             </a:pPr>
             <a:r>
-              <a:t>1. Sanket Kirdat (Roll: 4060 | PRN: 24065451263508)   •   2. Sakshi Bhagat (Roll: 4054 | PRN: 24065451263502)</a:t>
+              <a:t>1. Sanket Kirdat (Team Leader &amp; AI Dev | Roll: 4060)   •   2. Sakshi Bhagat (Frontend &amp; UI Dev | Roll: 4054)</a:t>
             </a:r>
           </a:p>
           <a:p>
@@ -3736,7 +3736,7 @@
               </a:defRPr>
             </a:pPr>
             <a:r>
-              <a:t>3. Vaishnavi Dhavale (Roll: 4056 | PRN: 24065451263504)   •   4. Rushikesh Mulik (Roll: 4004 | PRN: 23065451263005)</a:t>
+              <a:t>3. Vaishnavi Dhavale (Voice Billing &amp; AI Dev | Roll: 4056)   •   4. Rushikesh Mulik (Backend &amp; Database | Roll: 4004)</a:t>
             </a:r>
           </a:p>
           <a:p>
@@ -17841,11 +17841,11 @@
               </a:defRPr>
             </a:pPr>
             <a:r>
-              <a:t>Project Team: Sanket Kirdat (Roll: 4060 | PRN: 24065451263508) • Sakshi Bhagat (Roll: 4054 | PRN: 24065451263502)</a:t>
+              <a:t>Project Team: Sanket Kirdat (Team Leader &amp; AI Developer) • Sakshi Bhagat (Frontend &amp; UI Developer)</a:t>
             </a:r>
             <a:br/>
             <a:r>
-              <a:t>Vaishnavi Dhavale (Roll: 4056 | PRN: 24065451263504) • Rushikesh Mulik (Roll: 4004 | PRN: 23065451263005)</a:t>
+              <a:t>Vaishnavi Dhavale (Voice Billing &amp; AI Developer) • Rushikesh Mulik (Backend &amp; Database Developer)</a:t>
             </a:r>
           </a:p>
           <a:p>

</xml_diff>